<commit_message>
Update DAK_POC_Proposal_v2.pptx with latest changes
Co-Authored-By: Claude Opus 4.6 <noreply@anthropic.com>
</commit_message>
<xml_diff>
--- a/DAK_POC_Proposal_v2.pptx
+++ b/DAK_POC_Proposal_v2.pptx
@@ -5,11 +5,11 @@
     <p:sldMasterId id="2147483648" r:id="rId1"/>
   </p:sldMasterIdLst>
   <p:sldIdLst>
-    <p:sldId id="256" r:id="rId7"/>
-    <p:sldId id="257" r:id="rId8"/>
-    <p:sldId id="258" r:id="rId9"/>
+    <p:sldId id="256" r:id="rId2"/>
+    <p:sldId id="257" r:id="rId3"/>
+    <p:sldId id="258" r:id="rId4"/>
   </p:sldIdLst>
-  <p:sldSz cx="12191695" cy="6858000" type="screen4x3"/>
+  <p:sldSz cx="12192000" cy="6858000"/>
   <p:notesSz cx="6858000" cy="9144000"/>
   <p:defaultTextStyle>
     <a:defPPr>
@@ -106,6 +106,22 @@
       </a:defRPr>
     </a:lvl9pPr>
   </p:defaultTextStyle>
+  <p:extLst>
+    <p:ext uri="{EFAFB233-063F-42B5-8137-9DF3F51BA10A}">
+      <p15:sldGuideLst xmlns:p15="http://schemas.microsoft.com/office/powerpoint/2012/main">
+        <p15:guide id="1" orient="horz" pos="2160">
+          <p15:clr>
+            <a:srgbClr val="A4A3A4"/>
+          </p15:clr>
+        </p15:guide>
+        <p15:guide id="2" pos="2880">
+          <p15:clr>
+            <a:srgbClr val="A4A3A4"/>
+          </p15:clr>
+        </p15:guide>
+      </p15:sldGuideLst>
+    </p:ext>
+  </p:extLst>
 </p:presentation>
 </file>
 
@@ -147,10 +163,9 @@
           <a:lstStyle/>
           <a:p>
             <a:r>
-              <a:rPr lang="en-US" smtClean="0"/>
+              <a:rPr lang="en-US"/>
               <a:t>Click to edit Master title style</a:t>
             </a:r>
-            <a:endParaRPr lang="en-US"/>
           </a:p>
         </p:txBody>
       </p:sp>
@@ -266,10 +281,9 @@
           </a:lstStyle>
           <a:p>
             <a:r>
-              <a:rPr lang="en-US" smtClean="0"/>
+              <a:rPr lang="en-US"/>
               <a:t>Click to edit Master subtitle style</a:t>
             </a:r>
-            <a:endParaRPr lang="en-US"/>
           </a:p>
         </p:txBody>
       </p:sp>
@@ -290,7 +304,7 @@
           <a:p>
             <a:fld id="{5BCAD085-E8A6-8845-BD4E-CB4CCA059FC4}" type="datetimeFigureOut">
               <a:rPr lang="en-US" smtClean="0"/>
-              <a:t>1/27/13</a:t>
+              <a:t>2/13/2026</a:t>
             </a:fld>
             <a:endParaRPr lang="en-US"/>
           </a:p>
@@ -384,10 +398,9 @@
           <a:lstStyle/>
           <a:p>
             <a:r>
-              <a:rPr lang="en-US" smtClean="0"/>
+              <a:rPr lang="en-US"/>
               <a:t>Click to edit Master title style</a:t>
             </a:r>
-            <a:endParaRPr lang="en-US"/>
           </a:p>
         </p:txBody>
       </p:sp>
@@ -408,38 +421,37 @@
           <a:p>
             <a:pPr lvl="0"/>
             <a:r>
-              <a:rPr lang="en-US" smtClean="0"/>
+              <a:rPr lang="en-US"/>
               <a:t>Click to edit Master text styles</a:t>
             </a:r>
           </a:p>
           <a:p>
             <a:pPr lvl="1"/>
             <a:r>
-              <a:rPr lang="en-US" smtClean="0"/>
+              <a:rPr lang="en-US"/>
               <a:t>Second level</a:t>
             </a:r>
           </a:p>
           <a:p>
             <a:pPr lvl="2"/>
             <a:r>
-              <a:rPr lang="en-US" smtClean="0"/>
+              <a:rPr lang="en-US"/>
               <a:t>Third level</a:t>
             </a:r>
           </a:p>
           <a:p>
             <a:pPr lvl="3"/>
             <a:r>
-              <a:rPr lang="en-US" smtClean="0"/>
+              <a:rPr lang="en-US"/>
               <a:t>Fourth level</a:t>
             </a:r>
           </a:p>
           <a:p>
             <a:pPr lvl="4"/>
             <a:r>
-              <a:rPr lang="en-US" smtClean="0"/>
+              <a:rPr lang="en-US"/>
               <a:t>Fifth level</a:t>
             </a:r>
-            <a:endParaRPr lang="en-US"/>
           </a:p>
         </p:txBody>
       </p:sp>
@@ -460,7 +472,7 @@
           <a:p>
             <a:fld id="{5BCAD085-E8A6-8845-BD4E-CB4CCA059FC4}" type="datetimeFigureOut">
               <a:rPr lang="en-US" smtClean="0"/>
-              <a:t>1/27/13</a:t>
+              <a:t>2/13/2026</a:t>
             </a:fld>
             <a:endParaRPr lang="en-US"/>
           </a:p>
@@ -559,10 +571,9 @@
           <a:lstStyle/>
           <a:p>
             <a:r>
-              <a:rPr lang="en-US" smtClean="0"/>
+              <a:rPr lang="en-US"/>
               <a:t>Click to edit Master title style</a:t>
             </a:r>
-            <a:endParaRPr lang="en-US"/>
           </a:p>
         </p:txBody>
       </p:sp>
@@ -588,38 +599,37 @@
           <a:p>
             <a:pPr lvl="0"/>
             <a:r>
-              <a:rPr lang="en-US" smtClean="0"/>
+              <a:rPr lang="en-US"/>
               <a:t>Click to edit Master text styles</a:t>
             </a:r>
           </a:p>
           <a:p>
             <a:pPr lvl="1"/>
             <a:r>
-              <a:rPr lang="en-US" smtClean="0"/>
+              <a:rPr lang="en-US"/>
               <a:t>Second level</a:t>
             </a:r>
           </a:p>
           <a:p>
             <a:pPr lvl="2"/>
             <a:r>
-              <a:rPr lang="en-US" smtClean="0"/>
+              <a:rPr lang="en-US"/>
               <a:t>Third level</a:t>
             </a:r>
           </a:p>
           <a:p>
             <a:pPr lvl="3"/>
             <a:r>
-              <a:rPr lang="en-US" smtClean="0"/>
+              <a:rPr lang="en-US"/>
               <a:t>Fourth level</a:t>
             </a:r>
           </a:p>
           <a:p>
             <a:pPr lvl="4"/>
             <a:r>
-              <a:rPr lang="en-US" smtClean="0"/>
+              <a:rPr lang="en-US"/>
               <a:t>Fifth level</a:t>
             </a:r>
-            <a:endParaRPr lang="en-US"/>
           </a:p>
         </p:txBody>
       </p:sp>
@@ -640,7 +650,7 @@
           <a:p>
             <a:fld id="{5BCAD085-E8A6-8845-BD4E-CB4CCA059FC4}" type="datetimeFigureOut">
               <a:rPr lang="en-US" smtClean="0"/>
-              <a:t>1/27/13</a:t>
+              <a:t>2/13/2026</a:t>
             </a:fld>
             <a:endParaRPr lang="en-US"/>
           </a:p>
@@ -734,10 +744,9 @@
           <a:lstStyle/>
           <a:p>
             <a:r>
-              <a:rPr lang="en-US" smtClean="0"/>
+              <a:rPr lang="en-US"/>
               <a:t>Click to edit Master title style</a:t>
             </a:r>
-            <a:endParaRPr lang="en-US"/>
           </a:p>
         </p:txBody>
       </p:sp>
@@ -758,38 +767,37 @@
           <a:p>
             <a:pPr lvl="0"/>
             <a:r>
-              <a:rPr lang="en-US" smtClean="0"/>
+              <a:rPr lang="en-US"/>
               <a:t>Click to edit Master text styles</a:t>
             </a:r>
           </a:p>
           <a:p>
             <a:pPr lvl="1"/>
             <a:r>
-              <a:rPr lang="en-US" smtClean="0"/>
+              <a:rPr lang="en-US"/>
               <a:t>Second level</a:t>
             </a:r>
           </a:p>
           <a:p>
             <a:pPr lvl="2"/>
             <a:r>
-              <a:rPr lang="en-US" smtClean="0"/>
+              <a:rPr lang="en-US"/>
               <a:t>Third level</a:t>
             </a:r>
           </a:p>
           <a:p>
             <a:pPr lvl="3"/>
             <a:r>
-              <a:rPr lang="en-US" smtClean="0"/>
+              <a:rPr lang="en-US"/>
               <a:t>Fourth level</a:t>
             </a:r>
           </a:p>
           <a:p>
             <a:pPr lvl="4"/>
             <a:r>
-              <a:rPr lang="en-US" smtClean="0"/>
+              <a:rPr lang="en-US"/>
               <a:t>Fifth level</a:t>
             </a:r>
-            <a:endParaRPr lang="en-US"/>
           </a:p>
         </p:txBody>
       </p:sp>
@@ -810,7 +818,7 @@
           <a:p>
             <a:fld id="{5BCAD085-E8A6-8845-BD4E-CB4CCA059FC4}" type="datetimeFigureOut">
               <a:rPr lang="en-US" smtClean="0"/>
-              <a:t>1/27/13</a:t>
+              <a:t>2/13/2026</a:t>
             </a:fld>
             <a:endParaRPr lang="en-US"/>
           </a:p>
@@ -913,10 +921,9 @@
           </a:lstStyle>
           <a:p>
             <a:r>
-              <a:rPr lang="en-US" smtClean="0"/>
+              <a:rPr lang="en-US"/>
               <a:t>Click to edit Master title style</a:t>
             </a:r>
-            <a:endParaRPr lang="en-US"/>
           </a:p>
         </p:txBody>
       </p:sp>
@@ -1033,7 +1040,7 @@
           <a:p>
             <a:pPr lvl="0"/>
             <a:r>
-              <a:rPr lang="en-US" smtClean="0"/>
+              <a:rPr lang="en-US"/>
               <a:t>Click to edit Master text styles</a:t>
             </a:r>
           </a:p>
@@ -1056,7 +1063,7 @@
           <a:p>
             <a:fld id="{5BCAD085-E8A6-8845-BD4E-CB4CCA059FC4}" type="datetimeFigureOut">
               <a:rPr lang="en-US" smtClean="0"/>
-              <a:t>1/27/13</a:t>
+              <a:t>2/13/2026</a:t>
             </a:fld>
             <a:endParaRPr lang="en-US"/>
           </a:p>
@@ -1150,10 +1157,9 @@
           <a:lstStyle/>
           <a:p>
             <a:r>
-              <a:rPr lang="en-US" smtClean="0"/>
+              <a:rPr lang="en-US"/>
               <a:t>Click to edit Master title style</a:t>
             </a:r>
-            <a:endParaRPr lang="en-US"/>
           </a:p>
         </p:txBody>
       </p:sp>
@@ -1207,38 +1213,37 @@
           <a:p>
             <a:pPr lvl="0"/>
             <a:r>
-              <a:rPr lang="en-US" smtClean="0"/>
+              <a:rPr lang="en-US"/>
               <a:t>Click to edit Master text styles</a:t>
             </a:r>
           </a:p>
           <a:p>
             <a:pPr lvl="1"/>
             <a:r>
-              <a:rPr lang="en-US" smtClean="0"/>
+              <a:rPr lang="en-US"/>
               <a:t>Second level</a:t>
             </a:r>
           </a:p>
           <a:p>
             <a:pPr lvl="2"/>
             <a:r>
-              <a:rPr lang="en-US" smtClean="0"/>
+              <a:rPr lang="en-US"/>
               <a:t>Third level</a:t>
             </a:r>
           </a:p>
           <a:p>
             <a:pPr lvl="3"/>
             <a:r>
-              <a:rPr lang="en-US" smtClean="0"/>
+              <a:rPr lang="en-US"/>
               <a:t>Fourth level</a:t>
             </a:r>
           </a:p>
           <a:p>
             <a:pPr lvl="4"/>
             <a:r>
-              <a:rPr lang="en-US" smtClean="0"/>
+              <a:rPr lang="en-US"/>
               <a:t>Fifth level</a:t>
             </a:r>
-            <a:endParaRPr lang="en-US"/>
           </a:p>
         </p:txBody>
       </p:sp>
@@ -1292,38 +1297,37 @@
           <a:p>
             <a:pPr lvl="0"/>
             <a:r>
-              <a:rPr lang="en-US" smtClean="0"/>
+              <a:rPr lang="en-US"/>
               <a:t>Click to edit Master text styles</a:t>
             </a:r>
           </a:p>
           <a:p>
             <a:pPr lvl="1"/>
             <a:r>
-              <a:rPr lang="en-US" smtClean="0"/>
+              <a:rPr lang="en-US"/>
               <a:t>Second level</a:t>
             </a:r>
           </a:p>
           <a:p>
             <a:pPr lvl="2"/>
             <a:r>
-              <a:rPr lang="en-US" smtClean="0"/>
+              <a:rPr lang="en-US"/>
               <a:t>Third level</a:t>
             </a:r>
           </a:p>
           <a:p>
             <a:pPr lvl="3"/>
             <a:r>
-              <a:rPr lang="en-US" smtClean="0"/>
+              <a:rPr lang="en-US"/>
               <a:t>Fourth level</a:t>
             </a:r>
           </a:p>
           <a:p>
             <a:pPr lvl="4"/>
             <a:r>
-              <a:rPr lang="en-US" smtClean="0"/>
+              <a:rPr lang="en-US"/>
               <a:t>Fifth level</a:t>
             </a:r>
-            <a:endParaRPr lang="en-US"/>
           </a:p>
         </p:txBody>
       </p:sp>
@@ -1344,7 +1348,7 @@
           <a:p>
             <a:fld id="{5BCAD085-E8A6-8845-BD4E-CB4CCA059FC4}" type="datetimeFigureOut">
               <a:rPr lang="en-US" smtClean="0"/>
-              <a:t>1/27/13</a:t>
+              <a:t>2/13/2026</a:t>
             </a:fld>
             <a:endParaRPr lang="en-US"/>
           </a:p>
@@ -1442,10 +1446,9 @@
           </a:lstStyle>
           <a:p>
             <a:r>
-              <a:rPr lang="en-US" smtClean="0"/>
+              <a:rPr lang="en-US"/>
               <a:t>Click to edit Master title style</a:t>
             </a:r>
-            <a:endParaRPr lang="en-US"/>
           </a:p>
         </p:txBody>
       </p:sp>
@@ -1508,7 +1511,7 @@
           <a:p>
             <a:pPr lvl="0"/>
             <a:r>
-              <a:rPr lang="en-US" smtClean="0"/>
+              <a:rPr lang="en-US"/>
               <a:t>Click to edit Master text styles</a:t>
             </a:r>
           </a:p>
@@ -1564,38 +1567,37 @@
           <a:p>
             <a:pPr lvl="0"/>
             <a:r>
-              <a:rPr lang="en-US" smtClean="0"/>
+              <a:rPr lang="en-US"/>
               <a:t>Click to edit Master text styles</a:t>
             </a:r>
           </a:p>
           <a:p>
             <a:pPr lvl="1"/>
             <a:r>
-              <a:rPr lang="en-US" smtClean="0"/>
+              <a:rPr lang="en-US"/>
               <a:t>Second level</a:t>
             </a:r>
           </a:p>
           <a:p>
             <a:pPr lvl="2"/>
             <a:r>
-              <a:rPr lang="en-US" smtClean="0"/>
+              <a:rPr lang="en-US"/>
               <a:t>Third level</a:t>
             </a:r>
           </a:p>
           <a:p>
             <a:pPr lvl="3"/>
             <a:r>
-              <a:rPr lang="en-US" smtClean="0"/>
+              <a:rPr lang="en-US"/>
               <a:t>Fourth level</a:t>
             </a:r>
           </a:p>
           <a:p>
             <a:pPr lvl="4"/>
             <a:r>
-              <a:rPr lang="en-US" smtClean="0"/>
+              <a:rPr lang="en-US"/>
               <a:t>Fifth level</a:t>
             </a:r>
-            <a:endParaRPr lang="en-US"/>
           </a:p>
         </p:txBody>
       </p:sp>
@@ -1658,7 +1660,7 @@
           <a:p>
             <a:pPr lvl="0"/>
             <a:r>
-              <a:rPr lang="en-US" smtClean="0"/>
+              <a:rPr lang="en-US"/>
               <a:t>Click to edit Master text styles</a:t>
             </a:r>
           </a:p>
@@ -1714,38 +1716,37 @@
           <a:p>
             <a:pPr lvl="0"/>
             <a:r>
-              <a:rPr lang="en-US" smtClean="0"/>
+              <a:rPr lang="en-US"/>
               <a:t>Click to edit Master text styles</a:t>
             </a:r>
           </a:p>
           <a:p>
             <a:pPr lvl="1"/>
             <a:r>
-              <a:rPr lang="en-US" smtClean="0"/>
+              <a:rPr lang="en-US"/>
               <a:t>Second level</a:t>
             </a:r>
           </a:p>
           <a:p>
             <a:pPr lvl="2"/>
             <a:r>
-              <a:rPr lang="en-US" smtClean="0"/>
+              <a:rPr lang="en-US"/>
               <a:t>Third level</a:t>
             </a:r>
           </a:p>
           <a:p>
             <a:pPr lvl="3"/>
             <a:r>
-              <a:rPr lang="en-US" smtClean="0"/>
+              <a:rPr lang="en-US"/>
               <a:t>Fourth level</a:t>
             </a:r>
           </a:p>
           <a:p>
             <a:pPr lvl="4"/>
             <a:r>
-              <a:rPr lang="en-US" smtClean="0"/>
+              <a:rPr lang="en-US"/>
               <a:t>Fifth level</a:t>
             </a:r>
-            <a:endParaRPr lang="en-US"/>
           </a:p>
         </p:txBody>
       </p:sp>
@@ -1766,7 +1767,7 @@
           <a:p>
             <a:fld id="{5BCAD085-E8A6-8845-BD4E-CB4CCA059FC4}" type="datetimeFigureOut">
               <a:rPr lang="en-US" smtClean="0"/>
-              <a:t>1/27/13</a:t>
+              <a:t>2/13/2026</a:t>
             </a:fld>
             <a:endParaRPr lang="en-US"/>
           </a:p>
@@ -1860,10 +1861,9 @@
           <a:lstStyle/>
           <a:p>
             <a:r>
-              <a:rPr lang="en-US" smtClean="0"/>
+              <a:rPr lang="en-US"/>
               <a:t>Click to edit Master title style</a:t>
             </a:r>
-            <a:endParaRPr lang="en-US"/>
           </a:p>
         </p:txBody>
       </p:sp>
@@ -1884,7 +1884,7 @@
           <a:p>
             <a:fld id="{5BCAD085-E8A6-8845-BD4E-CB4CCA059FC4}" type="datetimeFigureOut">
               <a:rPr lang="en-US" smtClean="0"/>
-              <a:t>1/27/13</a:t>
+              <a:t>2/13/2026</a:t>
             </a:fld>
             <a:endParaRPr lang="en-US"/>
           </a:p>
@@ -1979,7 +1979,7 @@
           <a:p>
             <a:fld id="{5BCAD085-E8A6-8845-BD4E-CB4CCA059FC4}" type="datetimeFigureOut">
               <a:rPr lang="en-US" smtClean="0"/>
-              <a:t>1/27/13</a:t>
+              <a:t>2/13/2026</a:t>
             </a:fld>
             <a:endParaRPr lang="en-US"/>
           </a:p>
@@ -2082,10 +2082,9 @@
           </a:lstStyle>
           <a:p>
             <a:r>
-              <a:rPr lang="en-US" smtClean="0"/>
+              <a:rPr lang="en-US"/>
               <a:t>Click to edit Master title style</a:t>
             </a:r>
-            <a:endParaRPr lang="en-US"/>
           </a:p>
         </p:txBody>
       </p:sp>
@@ -2139,38 +2138,37 @@
           <a:p>
             <a:pPr lvl="0"/>
             <a:r>
-              <a:rPr lang="en-US" smtClean="0"/>
+              <a:rPr lang="en-US"/>
               <a:t>Click to edit Master text styles</a:t>
             </a:r>
           </a:p>
           <a:p>
             <a:pPr lvl="1"/>
             <a:r>
-              <a:rPr lang="en-US" smtClean="0"/>
+              <a:rPr lang="en-US"/>
               <a:t>Second level</a:t>
             </a:r>
           </a:p>
           <a:p>
             <a:pPr lvl="2"/>
             <a:r>
-              <a:rPr lang="en-US" smtClean="0"/>
+              <a:rPr lang="en-US"/>
               <a:t>Third level</a:t>
             </a:r>
           </a:p>
           <a:p>
             <a:pPr lvl="3"/>
             <a:r>
-              <a:rPr lang="en-US" smtClean="0"/>
+              <a:rPr lang="en-US"/>
               <a:t>Fourth level</a:t>
             </a:r>
           </a:p>
           <a:p>
             <a:pPr lvl="4"/>
             <a:r>
-              <a:rPr lang="en-US" smtClean="0"/>
+              <a:rPr lang="en-US"/>
               <a:t>Fifth level</a:t>
             </a:r>
-            <a:endParaRPr lang="en-US"/>
           </a:p>
         </p:txBody>
       </p:sp>
@@ -2233,7 +2231,7 @@
           <a:p>
             <a:pPr lvl="0"/>
             <a:r>
-              <a:rPr lang="en-US" smtClean="0"/>
+              <a:rPr lang="en-US"/>
               <a:t>Click to edit Master text styles</a:t>
             </a:r>
           </a:p>
@@ -2256,7 +2254,7 @@
           <a:p>
             <a:fld id="{5BCAD085-E8A6-8845-BD4E-CB4CCA059FC4}" type="datetimeFigureOut">
               <a:rPr lang="en-US" smtClean="0"/>
-              <a:t>1/27/13</a:t>
+              <a:t>2/13/2026</a:t>
             </a:fld>
             <a:endParaRPr lang="en-US"/>
           </a:p>
@@ -2359,10 +2357,9 @@
           </a:lstStyle>
           <a:p>
             <a:r>
-              <a:rPr lang="en-US" smtClean="0"/>
+              <a:rPr lang="en-US"/>
               <a:t>Click to edit Master title style</a:t>
             </a:r>
-            <a:endParaRPr lang="en-US"/>
           </a:p>
         </p:txBody>
       </p:sp>
@@ -2486,7 +2483,7 @@
           <a:p>
             <a:pPr lvl="0"/>
             <a:r>
-              <a:rPr lang="en-US" smtClean="0"/>
+              <a:rPr lang="en-US"/>
               <a:t>Click to edit Master text styles</a:t>
             </a:r>
           </a:p>
@@ -2509,7 +2506,7 @@
           <a:p>
             <a:fld id="{5BCAD085-E8A6-8845-BD4E-CB4CCA059FC4}" type="datetimeFigureOut">
               <a:rPr lang="en-US" smtClean="0"/>
-              <a:t>1/27/13</a:t>
+              <a:t>2/13/2026</a:t>
             </a:fld>
             <a:endParaRPr lang="en-US"/>
           </a:p>
@@ -2618,10 +2615,9 @@
           <a:lstStyle/>
           <a:p>
             <a:r>
-              <a:rPr lang="en-US" smtClean="0"/>
+              <a:rPr lang="en-US"/>
               <a:t>Click to edit Master title style</a:t>
             </a:r>
-            <a:endParaRPr lang="en-US"/>
           </a:p>
         </p:txBody>
       </p:sp>
@@ -2652,38 +2648,37 @@
           <a:p>
             <a:pPr lvl="0"/>
             <a:r>
-              <a:rPr lang="en-US" smtClean="0"/>
+              <a:rPr lang="en-US"/>
               <a:t>Click to edit Master text styles</a:t>
             </a:r>
           </a:p>
           <a:p>
             <a:pPr lvl="1"/>
             <a:r>
-              <a:rPr lang="en-US" smtClean="0"/>
+              <a:rPr lang="en-US"/>
               <a:t>Second level</a:t>
             </a:r>
           </a:p>
           <a:p>
             <a:pPr lvl="2"/>
             <a:r>
-              <a:rPr lang="en-US" smtClean="0"/>
+              <a:rPr lang="en-US"/>
               <a:t>Third level</a:t>
             </a:r>
           </a:p>
           <a:p>
             <a:pPr lvl="3"/>
             <a:r>
-              <a:rPr lang="en-US" smtClean="0"/>
+              <a:rPr lang="en-US"/>
               <a:t>Fourth level</a:t>
             </a:r>
           </a:p>
           <a:p>
             <a:pPr lvl="4"/>
             <a:r>
-              <a:rPr lang="en-US" smtClean="0"/>
+              <a:rPr lang="en-US"/>
               <a:t>Fifth level</a:t>
             </a:r>
-            <a:endParaRPr lang="en-US"/>
           </a:p>
         </p:txBody>
       </p:sp>
@@ -2722,7 +2717,7 @@
           <a:p>
             <a:fld id="{5BCAD085-E8A6-8845-BD4E-CB4CCA059FC4}" type="datetimeFigureOut">
               <a:rPr lang="en-US" smtClean="0"/>
-              <a:t>1/27/13</a:t>
+              <a:t>2/13/2026</a:t>
             </a:fld>
             <a:endParaRPr lang="en-US"/>
           </a:p>
@@ -3081,7 +3076,7 @@
 </file>
 
 <file path=ppt/slides/slide1.xml><?xml version="1.0" encoding="utf-8"?>
-<p:sld xmlns:a="http://schemas.openxmlformats.org/drawingml/2006/main" xmlns:p="http://schemas.openxmlformats.org/presentationml/2006/main" xmlns:r="http://schemas.openxmlformats.org/officeDocument/2006/relationships">
+<p:sld xmlns:a="http://schemas.openxmlformats.org/drawingml/2006/main" xmlns:r="http://schemas.openxmlformats.org/officeDocument/2006/relationships" xmlns:p="http://schemas.openxmlformats.org/presentationml/2006/main">
   <p:cSld>
     <p:bg>
       <p:bgPr>
@@ -3097,7 +3092,14 @@
         <p:cNvGrpSpPr/>
         <p:nvPr/>
       </p:nvGrpSpPr>
-      <p:grpSpPr/>
+      <p:grpSpPr>
+        <a:xfrm>
+          <a:off x="0" y="0"/>
+          <a:ext cx="0" cy="0"/>
+          <a:chOff x="0" y="0"/>
+          <a:chExt cx="0" cy="0"/>
+        </a:xfrm>
+      </p:grpSpPr>
       <p:sp>
         <p:nvSpPr>
           <p:cNvPr id="2" name="Rounded Rectangle 1"/>
@@ -3140,6 +3142,7 @@
           <a:lstStyle/>
           <a:p>
             <a:pPr algn="ctr"/>
+            <a:endParaRPr/>
           </a:p>
         </p:txBody>
       </p:sp>
@@ -3327,6 +3330,7 @@
           <a:lstStyle/>
           <a:p>
             <a:pPr algn="ctr"/>
+            <a:endParaRPr/>
           </a:p>
         </p:txBody>
       </p:sp>
@@ -3408,6 +3412,7 @@
           <a:lstStyle/>
           <a:p>
             <a:pPr algn="ctr"/>
+            <a:endParaRPr/>
           </a:p>
         </p:txBody>
       </p:sp>
@@ -3487,6 +3492,7 @@
           <a:lstStyle/>
           <a:p>
             <a:pPr algn="ctr"/>
+            <a:endParaRPr/>
           </a:p>
         </p:txBody>
       </p:sp>
@@ -3530,6 +3536,7 @@
           <a:lstStyle/>
           <a:p>
             <a:pPr algn="ctr"/>
+            <a:endParaRPr/>
           </a:p>
         </p:txBody>
       </p:sp>
@@ -3575,6 +3582,7 @@
           <a:lstStyle/>
           <a:p>
             <a:pPr algn="ctr"/>
+            <a:endParaRPr/>
           </a:p>
         </p:txBody>
       </p:sp>
@@ -3688,6 +3696,7 @@
           <a:lstStyle/>
           <a:p>
             <a:pPr algn="ctr"/>
+            <a:endParaRPr/>
           </a:p>
         </p:txBody>
       </p:sp>
@@ -3733,6 +3742,7 @@
           <a:lstStyle/>
           <a:p>
             <a:pPr algn="ctr"/>
+            <a:endParaRPr/>
           </a:p>
         </p:txBody>
       </p:sp>
@@ -3846,6 +3856,7 @@
           <a:lstStyle/>
           <a:p>
             <a:pPr algn="ctr"/>
+            <a:endParaRPr/>
           </a:p>
         </p:txBody>
       </p:sp>
@@ -3891,6 +3902,7 @@
           <a:lstStyle/>
           <a:p>
             <a:pPr algn="ctr"/>
+            <a:endParaRPr/>
           </a:p>
         </p:txBody>
       </p:sp>
@@ -4004,6 +4016,7 @@
           <a:lstStyle/>
           <a:p>
             <a:pPr algn="ctr"/>
+            <a:endParaRPr/>
           </a:p>
         </p:txBody>
       </p:sp>
@@ -4049,6 +4062,7 @@
           <a:lstStyle/>
           <a:p>
             <a:pPr algn="ctr"/>
+            <a:endParaRPr/>
           </a:p>
         </p:txBody>
       </p:sp>
@@ -4162,6 +4176,7 @@
           <a:lstStyle/>
           <a:p>
             <a:pPr algn="ctr"/>
+            <a:endParaRPr/>
           </a:p>
         </p:txBody>
       </p:sp>
@@ -4207,6 +4222,7 @@
           <a:lstStyle/>
           <a:p>
             <a:pPr algn="ctr"/>
+            <a:endParaRPr/>
           </a:p>
         </p:txBody>
       </p:sp>
@@ -4320,6 +4336,7 @@
           <a:lstStyle/>
           <a:p>
             <a:pPr algn="ctr"/>
+            <a:endParaRPr/>
           </a:p>
         </p:txBody>
       </p:sp>
@@ -4365,6 +4382,7 @@
           <a:lstStyle/>
           <a:p>
             <a:pPr algn="ctr"/>
+            <a:endParaRPr/>
           </a:p>
         </p:txBody>
       </p:sp>
@@ -4480,6 +4498,7 @@
           <a:lstStyle/>
           <a:p>
             <a:pPr algn="ctr"/>
+            <a:endParaRPr/>
           </a:p>
         </p:txBody>
       </p:sp>
@@ -4559,6 +4578,7 @@
           <a:lstStyle/>
           <a:p>
             <a:pPr algn="ctr"/>
+            <a:endParaRPr/>
           </a:p>
         </p:txBody>
       </p:sp>
@@ -5593,7 +5613,7 @@
 </file>
 
 <file path=ppt/slides/slide2.xml><?xml version="1.0" encoding="utf-8"?>
-<p:sld xmlns:a="http://schemas.openxmlformats.org/drawingml/2006/main" xmlns:p="http://schemas.openxmlformats.org/presentationml/2006/main" xmlns:r="http://schemas.openxmlformats.org/officeDocument/2006/relationships">
+<p:sld xmlns:a="http://schemas.openxmlformats.org/drawingml/2006/main" xmlns:r="http://schemas.openxmlformats.org/officeDocument/2006/relationships" xmlns:p="http://schemas.openxmlformats.org/presentationml/2006/main">
   <p:cSld>
     <p:bg>
       <p:bgPr>
@@ -5609,7 +5629,14 @@
         <p:cNvGrpSpPr/>
         <p:nvPr/>
       </p:nvGrpSpPr>
-      <p:grpSpPr/>
+      <p:grpSpPr>
+        <a:xfrm>
+          <a:off x="0" y="0"/>
+          <a:ext cx="0" cy="0"/>
+          <a:chOff x="0" y="0"/>
+          <a:chExt cx="0" cy="0"/>
+        </a:xfrm>
+      </p:grpSpPr>
       <p:sp>
         <p:nvSpPr>
           <p:cNvPr id="2" name="Rounded Rectangle 1"/>
@@ -5652,6 +5679,7 @@
           <a:lstStyle/>
           <a:p>
             <a:pPr algn="ctr"/>
+            <a:endParaRPr/>
           </a:p>
         </p:txBody>
       </p:sp>
@@ -5839,6 +5867,7 @@
           <a:lstStyle/>
           <a:p>
             <a:pPr algn="ctr"/>
+            <a:endParaRPr/>
           </a:p>
         </p:txBody>
       </p:sp>
@@ -5920,6 +5949,7 @@
           <a:lstStyle/>
           <a:p>
             <a:pPr algn="ctr"/>
+            <a:endParaRPr/>
           </a:p>
         </p:txBody>
       </p:sp>
@@ -5965,6 +5995,7 @@
           <a:lstStyle/>
           <a:p>
             <a:pPr algn="ctr"/>
+            <a:endParaRPr/>
           </a:p>
         </p:txBody>
       </p:sp>
@@ -6101,6 +6132,7 @@
           <a:lstStyle/>
           <a:p>
             <a:pPr algn="ctr"/>
+            <a:endParaRPr/>
           </a:p>
         </p:txBody>
       </p:sp>
@@ -6180,6 +6212,7 @@
           <a:lstStyle/>
           <a:p>
             <a:pPr algn="ctr"/>
+            <a:endParaRPr/>
           </a:p>
         </p:txBody>
       </p:sp>
@@ -6259,6 +6292,7 @@
           <a:lstStyle/>
           <a:p>
             <a:pPr algn="ctr"/>
+            <a:endParaRPr/>
           </a:p>
         </p:txBody>
       </p:sp>
@@ -6338,6 +6372,7 @@
           <a:lstStyle/>
           <a:p>
             <a:pPr algn="ctr"/>
+            <a:endParaRPr/>
           </a:p>
         </p:txBody>
       </p:sp>
@@ -6417,6 +6452,7 @@
           <a:lstStyle/>
           <a:p>
             <a:pPr algn="ctr"/>
+            <a:endParaRPr/>
           </a:p>
         </p:txBody>
       </p:sp>
@@ -6496,6 +6532,7 @@
           <a:lstStyle/>
           <a:p>
             <a:pPr algn="ctr"/>
+            <a:endParaRPr/>
           </a:p>
         </p:txBody>
       </p:sp>
@@ -6575,6 +6612,7 @@
           <a:lstStyle/>
           <a:p>
             <a:pPr algn="ctr"/>
+            <a:endParaRPr/>
           </a:p>
         </p:txBody>
       </p:sp>
@@ -6654,6 +6692,7 @@
           <a:lstStyle/>
           <a:p>
             <a:pPr algn="ctr"/>
+            <a:endParaRPr/>
           </a:p>
         </p:txBody>
       </p:sp>
@@ -6699,6 +6738,7 @@
           <a:lstStyle/>
           <a:p>
             <a:pPr algn="ctr"/>
+            <a:endParaRPr/>
           </a:p>
         </p:txBody>
       </p:sp>
@@ -6744,6 +6784,7 @@
           <a:lstStyle/>
           <a:p>
             <a:pPr algn="ctr"/>
+            <a:endParaRPr/>
           </a:p>
         </p:txBody>
       </p:sp>
@@ -6880,6 +6921,7 @@
           <a:lstStyle/>
           <a:p>
             <a:pPr algn="ctr"/>
+            <a:endParaRPr/>
           </a:p>
         </p:txBody>
       </p:sp>
@@ -6963,6 +7005,7 @@
           <a:lstStyle/>
           <a:p>
             <a:pPr algn="ctr"/>
+            <a:endParaRPr/>
           </a:p>
         </p:txBody>
       </p:sp>
@@ -7042,6 +7085,7 @@
           <a:lstStyle/>
           <a:p>
             <a:pPr algn="ctr"/>
+            <a:endParaRPr/>
           </a:p>
         </p:txBody>
       </p:sp>
@@ -7121,6 +7165,7 @@
           <a:lstStyle/>
           <a:p>
             <a:pPr algn="ctr"/>
+            <a:endParaRPr/>
           </a:p>
         </p:txBody>
       </p:sp>
@@ -7200,6 +7245,7 @@
           <a:lstStyle/>
           <a:p>
             <a:pPr algn="ctr"/>
+            <a:endParaRPr/>
           </a:p>
         </p:txBody>
       </p:sp>
@@ -7279,6 +7325,7 @@
           <a:lstStyle/>
           <a:p>
             <a:pPr algn="ctr"/>
+            <a:endParaRPr/>
           </a:p>
         </p:txBody>
       </p:sp>
@@ -7358,6 +7405,7 @@
           <a:lstStyle/>
           <a:p>
             <a:pPr algn="ctr"/>
+            <a:endParaRPr/>
           </a:p>
         </p:txBody>
       </p:sp>
@@ -7403,6 +7451,7 @@
           <a:lstStyle/>
           <a:p>
             <a:pPr algn="ctr"/>
+            <a:endParaRPr/>
           </a:p>
         </p:txBody>
       </p:sp>
@@ -7448,6 +7497,7 @@
           <a:lstStyle/>
           <a:p>
             <a:pPr algn="ctr"/>
+            <a:endParaRPr/>
           </a:p>
         </p:txBody>
       </p:sp>
@@ -7584,6 +7634,7 @@
           <a:lstStyle/>
           <a:p>
             <a:pPr algn="ctr"/>
+            <a:endParaRPr/>
           </a:p>
         </p:txBody>
       </p:sp>
@@ -7663,6 +7714,7 @@
           <a:lstStyle/>
           <a:p>
             <a:pPr algn="ctr"/>
+            <a:endParaRPr/>
           </a:p>
         </p:txBody>
       </p:sp>
@@ -7742,6 +7794,7 @@
           <a:lstStyle/>
           <a:p>
             <a:pPr algn="ctr"/>
+            <a:endParaRPr/>
           </a:p>
         </p:txBody>
       </p:sp>
@@ -7821,6 +7874,7 @@
           <a:lstStyle/>
           <a:p>
             <a:pPr algn="ctr"/>
+            <a:endParaRPr/>
           </a:p>
         </p:txBody>
       </p:sp>
@@ -7900,6 +7954,7 @@
           <a:lstStyle/>
           <a:p>
             <a:pPr algn="ctr"/>
+            <a:endParaRPr/>
           </a:p>
         </p:txBody>
       </p:sp>
@@ -7979,6 +8034,7 @@
           <a:lstStyle/>
           <a:p>
             <a:pPr algn="ctr"/>
+            <a:endParaRPr/>
           </a:p>
         </p:txBody>
       </p:sp>
@@ -8058,6 +8114,7 @@
           <a:lstStyle/>
           <a:p>
             <a:pPr algn="ctr"/>
+            <a:endParaRPr/>
           </a:p>
         </p:txBody>
       </p:sp>
@@ -8103,6 +8160,7 @@
           <a:lstStyle/>
           <a:p>
             <a:pPr algn="ctr"/>
+            <a:endParaRPr/>
           </a:p>
         </p:txBody>
       </p:sp>
@@ -8148,6 +8206,7 @@
           <a:lstStyle/>
           <a:p>
             <a:pPr algn="ctr"/>
+            <a:endParaRPr/>
           </a:p>
         </p:txBody>
       </p:sp>
@@ -8284,6 +8343,7 @@
           <a:lstStyle/>
           <a:p>
             <a:pPr algn="ctr"/>
+            <a:endParaRPr/>
           </a:p>
         </p:txBody>
       </p:sp>
@@ -8363,6 +8423,7 @@
           <a:lstStyle/>
           <a:p>
             <a:pPr algn="ctr"/>
+            <a:endParaRPr/>
           </a:p>
         </p:txBody>
       </p:sp>
@@ -8442,6 +8503,7 @@
           <a:lstStyle/>
           <a:p>
             <a:pPr algn="ctr"/>
+            <a:endParaRPr/>
           </a:p>
         </p:txBody>
       </p:sp>
@@ -8521,6 +8583,7 @@
           <a:lstStyle/>
           <a:p>
             <a:pPr algn="ctr"/>
+            <a:endParaRPr/>
           </a:p>
         </p:txBody>
       </p:sp>
@@ -8600,6 +8663,7 @@
           <a:lstStyle/>
           <a:p>
             <a:pPr algn="ctr"/>
+            <a:endParaRPr/>
           </a:p>
         </p:txBody>
       </p:sp>
@@ -8679,6 +8743,7 @@
           <a:lstStyle/>
           <a:p>
             <a:pPr algn="ctr"/>
+            <a:endParaRPr/>
           </a:p>
         </p:txBody>
       </p:sp>
@@ -8758,6 +8823,7 @@
           <a:lstStyle/>
           <a:p>
             <a:pPr algn="ctr"/>
+            <a:endParaRPr/>
           </a:p>
         </p:txBody>
       </p:sp>
@@ -8803,6 +8869,7 @@
           <a:lstStyle/>
           <a:p>
             <a:pPr algn="ctr"/>
+            <a:endParaRPr/>
           </a:p>
         </p:txBody>
       </p:sp>
@@ -8848,6 +8915,7 @@
           <a:lstStyle/>
           <a:p>
             <a:pPr algn="ctr"/>
+            <a:endParaRPr/>
           </a:p>
         </p:txBody>
       </p:sp>
@@ -8984,6 +9052,7 @@
           <a:lstStyle/>
           <a:p>
             <a:pPr algn="ctr"/>
+            <a:endParaRPr/>
           </a:p>
         </p:txBody>
       </p:sp>
@@ -9063,6 +9132,7 @@
           <a:lstStyle/>
           <a:p>
             <a:pPr algn="ctr"/>
+            <a:endParaRPr/>
           </a:p>
         </p:txBody>
       </p:sp>
@@ -9142,6 +9212,7 @@
           <a:lstStyle/>
           <a:p>
             <a:pPr algn="ctr"/>
+            <a:endParaRPr/>
           </a:p>
         </p:txBody>
       </p:sp>
@@ -9221,6 +9292,7 @@
           <a:lstStyle/>
           <a:p>
             <a:pPr algn="ctr"/>
+            <a:endParaRPr/>
           </a:p>
         </p:txBody>
       </p:sp>
@@ -9300,6 +9372,7 @@
           <a:lstStyle/>
           <a:p>
             <a:pPr algn="ctr"/>
+            <a:endParaRPr/>
           </a:p>
         </p:txBody>
       </p:sp>
@@ -9379,6 +9452,7 @@
           <a:lstStyle/>
           <a:p>
             <a:pPr algn="ctr"/>
+            <a:endParaRPr/>
           </a:p>
         </p:txBody>
       </p:sp>
@@ -9460,6 +9534,7 @@
           <a:lstStyle/>
           <a:p>
             <a:pPr algn="ctr"/>
+            <a:endParaRPr/>
           </a:p>
         </p:txBody>
       </p:sp>
@@ -9795,7 +9870,7 @@
 </file>
 
 <file path=ppt/slides/slide3.xml><?xml version="1.0" encoding="utf-8"?>
-<p:sld xmlns:a="http://schemas.openxmlformats.org/drawingml/2006/main" xmlns:p="http://schemas.openxmlformats.org/presentationml/2006/main" xmlns:r="http://schemas.openxmlformats.org/officeDocument/2006/relationships">
+<p:sld xmlns:a="http://schemas.openxmlformats.org/drawingml/2006/main" xmlns:r="http://schemas.openxmlformats.org/officeDocument/2006/relationships" xmlns:p="http://schemas.openxmlformats.org/presentationml/2006/main">
   <p:cSld>
     <p:bg>
       <p:bgPr>
@@ -9811,7 +9886,14 @@
         <p:cNvGrpSpPr/>
         <p:nvPr/>
       </p:nvGrpSpPr>
-      <p:grpSpPr/>
+      <p:grpSpPr>
+        <a:xfrm>
+          <a:off x="0" y="0"/>
+          <a:ext cx="0" cy="0"/>
+          <a:chOff x="0" y="0"/>
+          <a:chExt cx="0" cy="0"/>
+        </a:xfrm>
+      </p:grpSpPr>
       <p:sp>
         <p:nvSpPr>
           <p:cNvPr id="2" name="Rounded Rectangle 1"/>
@@ -9854,6 +9936,7 @@
           <a:lstStyle/>
           <a:p>
             <a:pPr algn="ctr"/>
+            <a:endParaRPr/>
           </a:p>
         </p:txBody>
       </p:sp>
@@ -10041,6 +10124,7 @@
           <a:lstStyle/>
           <a:p>
             <a:pPr algn="ctr"/>
+            <a:endParaRPr/>
           </a:p>
         </p:txBody>
       </p:sp>
@@ -10088,7 +10172,7 @@
         </p:nvSpPr>
         <p:spPr>
           <a:xfrm>
-            <a:off x="457200" y="1600200"/>
+            <a:off x="457200" y="1703070"/>
             <a:ext cx="3566160" cy="2788920"/>
           </a:xfrm>
           <a:prstGeom prst="roundRect">
@@ -10122,6 +10206,7 @@
           <a:lstStyle/>
           <a:p>
             <a:pPr algn="ctr"/>
+            <a:endParaRPr/>
           </a:p>
         </p:txBody>
       </p:sp>
@@ -10133,7 +10218,7 @@
         </p:nvSpPr>
         <p:spPr>
           <a:xfrm>
-            <a:off x="457200" y="1600200"/>
+            <a:off x="457200" y="1703070"/>
             <a:ext cx="3566160" cy="411480"/>
           </a:xfrm>
           <a:prstGeom prst="rect">
@@ -10167,6 +10252,7 @@
           <a:lstStyle/>
           <a:p>
             <a:pPr algn="ctr"/>
+            <a:endParaRPr/>
           </a:p>
         </p:txBody>
       </p:sp>
@@ -10178,7 +10264,7 @@
         </p:nvSpPr>
         <p:spPr>
           <a:xfrm>
-            <a:off x="640080" y="1673352"/>
+            <a:off x="640080" y="1776222"/>
             <a:ext cx="3200400" cy="274320"/>
           </a:xfrm>
           <a:prstGeom prst="rect">
@@ -10214,7 +10300,7 @@
         </p:nvSpPr>
         <p:spPr>
           <a:xfrm>
-            <a:off x="640080" y="2103120"/>
+            <a:off x="640080" y="2205990"/>
             <a:ext cx="2068372" cy="228600"/>
           </a:xfrm>
           <a:prstGeom prst="rect">
@@ -10250,7 +10336,7 @@
         </p:nvSpPr>
         <p:spPr>
           <a:xfrm>
-            <a:off x="2311603" y="2103120"/>
+            <a:off x="2311603" y="2205990"/>
             <a:ext cx="1497787" cy="228600"/>
           </a:xfrm>
           <a:prstGeom prst="rect">
@@ -10286,7 +10372,7 @@
         </p:nvSpPr>
         <p:spPr>
           <a:xfrm>
-            <a:off x="640080" y="2350008"/>
+            <a:off x="640080" y="2452878"/>
             <a:ext cx="3200400" cy="4572"/>
           </a:xfrm>
           <a:prstGeom prst="rect">
@@ -10318,6 +10404,7 @@
           <a:lstStyle/>
           <a:p>
             <a:pPr algn="ctr"/>
+            <a:endParaRPr/>
           </a:p>
         </p:txBody>
       </p:sp>
@@ -10329,7 +10416,7 @@
         </p:nvSpPr>
         <p:spPr>
           <a:xfrm>
-            <a:off x="640080" y="2395727"/>
+            <a:off x="640080" y="2498597"/>
             <a:ext cx="2068372" cy="228600"/>
           </a:xfrm>
           <a:prstGeom prst="rect">
@@ -10365,7 +10452,7 @@
         </p:nvSpPr>
         <p:spPr>
           <a:xfrm>
-            <a:off x="2311603" y="2395727"/>
+            <a:off x="2311603" y="2498597"/>
             <a:ext cx="1497787" cy="228600"/>
           </a:xfrm>
           <a:prstGeom prst="rect">
@@ -10401,7 +10488,7 @@
         </p:nvSpPr>
         <p:spPr>
           <a:xfrm>
-            <a:off x="640080" y="2642615"/>
+            <a:off x="640080" y="2745485"/>
             <a:ext cx="3200400" cy="4572"/>
           </a:xfrm>
           <a:prstGeom prst="rect">
@@ -10433,6 +10520,7 @@
           <a:lstStyle/>
           <a:p>
             <a:pPr algn="ctr"/>
+            <a:endParaRPr/>
           </a:p>
         </p:txBody>
       </p:sp>
@@ -10444,7 +10532,7 @@
         </p:nvSpPr>
         <p:spPr>
           <a:xfrm>
-            <a:off x="640080" y="2688335"/>
+            <a:off x="640080" y="2791205"/>
             <a:ext cx="2068372" cy="228600"/>
           </a:xfrm>
           <a:prstGeom prst="rect">
@@ -10480,7 +10568,7 @@
         </p:nvSpPr>
         <p:spPr>
           <a:xfrm>
-            <a:off x="2311603" y="2688335"/>
+            <a:off x="2311603" y="2791205"/>
             <a:ext cx="1497787" cy="228600"/>
           </a:xfrm>
           <a:prstGeom prst="rect">
@@ -10516,7 +10604,7 @@
         </p:nvSpPr>
         <p:spPr>
           <a:xfrm>
-            <a:off x="640080" y="2935223"/>
+            <a:off x="640080" y="3038093"/>
             <a:ext cx="3200400" cy="4572"/>
           </a:xfrm>
           <a:prstGeom prst="rect">
@@ -10548,6 +10636,7 @@
           <a:lstStyle/>
           <a:p>
             <a:pPr algn="ctr"/>
+            <a:endParaRPr/>
           </a:p>
         </p:txBody>
       </p:sp>
@@ -10559,7 +10648,7 @@
         </p:nvSpPr>
         <p:spPr>
           <a:xfrm>
-            <a:off x="640080" y="2980943"/>
+            <a:off x="640080" y="3083813"/>
             <a:ext cx="2068372" cy="228600"/>
           </a:xfrm>
           <a:prstGeom prst="rect">
@@ -10595,7 +10684,7 @@
         </p:nvSpPr>
         <p:spPr>
           <a:xfrm>
-            <a:off x="2311603" y="2980943"/>
+            <a:off x="2311603" y="3083813"/>
             <a:ext cx="1497787" cy="228600"/>
           </a:xfrm>
           <a:prstGeom prst="rect">
@@ -10631,7 +10720,7 @@
         </p:nvSpPr>
         <p:spPr>
           <a:xfrm>
-            <a:off x="640080" y="3227831"/>
+            <a:off x="640080" y="3330701"/>
             <a:ext cx="3200400" cy="4572"/>
           </a:xfrm>
           <a:prstGeom prst="rect">
@@ -10663,6 +10752,7 @@
           <a:lstStyle/>
           <a:p>
             <a:pPr algn="ctr"/>
+            <a:endParaRPr/>
           </a:p>
         </p:txBody>
       </p:sp>
@@ -10674,7 +10764,7 @@
         </p:nvSpPr>
         <p:spPr>
           <a:xfrm>
-            <a:off x="640080" y="3273551"/>
+            <a:off x="640080" y="3376421"/>
             <a:ext cx="2068372" cy="228600"/>
           </a:xfrm>
           <a:prstGeom prst="rect">
@@ -10710,7 +10800,7 @@
         </p:nvSpPr>
         <p:spPr>
           <a:xfrm>
-            <a:off x="2311603" y="3273551"/>
+            <a:off x="2311603" y="3376421"/>
             <a:ext cx="1497787" cy="228600"/>
           </a:xfrm>
           <a:prstGeom prst="rect">
@@ -10746,7 +10836,7 @@
         </p:nvSpPr>
         <p:spPr>
           <a:xfrm>
-            <a:off x="640080" y="3520439"/>
+            <a:off x="640080" y="3623309"/>
             <a:ext cx="3200400" cy="4572"/>
           </a:xfrm>
           <a:prstGeom prst="rect">
@@ -10778,6 +10868,7 @@
           <a:lstStyle/>
           <a:p>
             <a:pPr algn="ctr"/>
+            <a:endParaRPr/>
           </a:p>
         </p:txBody>
       </p:sp>
@@ -10789,7 +10880,7 @@
         </p:nvSpPr>
         <p:spPr>
           <a:xfrm>
-            <a:off x="640080" y="3611879"/>
+            <a:off x="640080" y="3714749"/>
             <a:ext cx="3200400" cy="18288"/>
           </a:xfrm>
           <a:prstGeom prst="rect">
@@ -10821,6 +10912,7 @@
           <a:lstStyle/>
           <a:p>
             <a:pPr algn="ctr"/>
+            <a:endParaRPr/>
           </a:p>
         </p:txBody>
       </p:sp>
@@ -10832,7 +10924,7 @@
         </p:nvSpPr>
         <p:spPr>
           <a:xfrm>
-            <a:off x="640080" y="3685031"/>
+            <a:off x="640080" y="3787901"/>
             <a:ext cx="1783080" cy="274320"/>
           </a:xfrm>
           <a:prstGeom prst="rect">
@@ -10868,7 +10960,7 @@
         </p:nvSpPr>
         <p:spPr>
           <a:xfrm>
-            <a:off x="2061972" y="3685031"/>
+            <a:off x="2061972" y="3787901"/>
             <a:ext cx="1783080" cy="274320"/>
           </a:xfrm>
           <a:prstGeom prst="rect">
@@ -10904,7 +10996,7 @@
         </p:nvSpPr>
         <p:spPr>
           <a:xfrm>
-            <a:off x="4297680" y="1600200"/>
+            <a:off x="4297680" y="1703070"/>
             <a:ext cx="3566160" cy="2788920"/>
           </a:xfrm>
           <a:prstGeom prst="roundRect">
@@ -10938,6 +11030,7 @@
           <a:lstStyle/>
           <a:p>
             <a:pPr algn="ctr"/>
+            <a:endParaRPr/>
           </a:p>
         </p:txBody>
       </p:sp>
@@ -10949,7 +11042,7 @@
         </p:nvSpPr>
         <p:spPr>
           <a:xfrm>
-            <a:off x="4297680" y="1600200"/>
+            <a:off x="4297680" y="1703070"/>
             <a:ext cx="3566160" cy="411480"/>
           </a:xfrm>
           <a:prstGeom prst="rect">
@@ -10983,6 +11076,7 @@
           <a:lstStyle/>
           <a:p>
             <a:pPr algn="ctr"/>
+            <a:endParaRPr/>
           </a:p>
         </p:txBody>
       </p:sp>
@@ -10994,7 +11088,7 @@
         </p:nvSpPr>
         <p:spPr>
           <a:xfrm>
-            <a:off x="4480560" y="1673352"/>
+            <a:off x="4480560" y="1776222"/>
             <a:ext cx="3200400" cy="274320"/>
           </a:xfrm>
           <a:prstGeom prst="rect">
@@ -11030,7 +11124,7 @@
         </p:nvSpPr>
         <p:spPr>
           <a:xfrm>
-            <a:off x="4480560" y="2103120"/>
+            <a:off x="4480560" y="2205990"/>
             <a:ext cx="2068372" cy="228600"/>
           </a:xfrm>
           <a:prstGeom prst="rect">
@@ -11066,7 +11160,7 @@
         </p:nvSpPr>
         <p:spPr>
           <a:xfrm>
-            <a:off x="6152083" y="2103120"/>
+            <a:off x="6152083" y="2205990"/>
             <a:ext cx="1497787" cy="228600"/>
           </a:xfrm>
           <a:prstGeom prst="rect">
@@ -11102,7 +11196,7 @@
         </p:nvSpPr>
         <p:spPr>
           <a:xfrm>
-            <a:off x="4480560" y="2350008"/>
+            <a:off x="4480560" y="2452878"/>
             <a:ext cx="3200400" cy="4572"/>
           </a:xfrm>
           <a:prstGeom prst="rect">
@@ -11134,6 +11228,7 @@
           <a:lstStyle/>
           <a:p>
             <a:pPr algn="ctr"/>
+            <a:endParaRPr/>
           </a:p>
         </p:txBody>
       </p:sp>
@@ -11145,7 +11240,7 @@
         </p:nvSpPr>
         <p:spPr>
           <a:xfrm>
-            <a:off x="4480560" y="2395727"/>
+            <a:off x="4480560" y="2498597"/>
             <a:ext cx="2068372" cy="228600"/>
           </a:xfrm>
           <a:prstGeom prst="rect">
@@ -11181,7 +11276,7 @@
         </p:nvSpPr>
         <p:spPr>
           <a:xfrm>
-            <a:off x="6152083" y="2395727"/>
+            <a:off x="6152083" y="2498597"/>
             <a:ext cx="1497787" cy="228600"/>
           </a:xfrm>
           <a:prstGeom prst="rect">
@@ -11217,7 +11312,7 @@
         </p:nvSpPr>
         <p:spPr>
           <a:xfrm>
-            <a:off x="4480560" y="2642615"/>
+            <a:off x="4480560" y="2745485"/>
             <a:ext cx="3200400" cy="4572"/>
           </a:xfrm>
           <a:prstGeom prst="rect">
@@ -11249,6 +11344,7 @@
           <a:lstStyle/>
           <a:p>
             <a:pPr algn="ctr"/>
+            <a:endParaRPr/>
           </a:p>
         </p:txBody>
       </p:sp>
@@ -11260,7 +11356,7 @@
         </p:nvSpPr>
         <p:spPr>
           <a:xfrm>
-            <a:off x="4480560" y="2688335"/>
+            <a:off x="4480560" y="2791205"/>
             <a:ext cx="2068372" cy="228600"/>
           </a:xfrm>
           <a:prstGeom prst="rect">
@@ -11296,7 +11392,7 @@
         </p:nvSpPr>
         <p:spPr>
           <a:xfrm>
-            <a:off x="6152083" y="2688335"/>
+            <a:off x="6152083" y="2791205"/>
             <a:ext cx="1497787" cy="228600"/>
           </a:xfrm>
           <a:prstGeom prst="rect">
@@ -11332,7 +11428,7 @@
         </p:nvSpPr>
         <p:spPr>
           <a:xfrm>
-            <a:off x="4480560" y="2935223"/>
+            <a:off x="4480560" y="3038093"/>
             <a:ext cx="3200400" cy="4572"/>
           </a:xfrm>
           <a:prstGeom prst="rect">
@@ -11364,6 +11460,7 @@
           <a:lstStyle/>
           <a:p>
             <a:pPr algn="ctr"/>
+            <a:endParaRPr/>
           </a:p>
         </p:txBody>
       </p:sp>
@@ -11375,7 +11472,7 @@
         </p:nvSpPr>
         <p:spPr>
           <a:xfrm>
-            <a:off x="4480560" y="2980943"/>
+            <a:off x="4480560" y="3083813"/>
             <a:ext cx="2068372" cy="228600"/>
           </a:xfrm>
           <a:prstGeom prst="rect">
@@ -11411,7 +11508,7 @@
         </p:nvSpPr>
         <p:spPr>
           <a:xfrm>
-            <a:off x="6152083" y="2980943"/>
+            <a:off x="6152083" y="3083813"/>
             <a:ext cx="1497787" cy="228600"/>
           </a:xfrm>
           <a:prstGeom prst="rect">
@@ -11447,7 +11544,7 @@
         </p:nvSpPr>
         <p:spPr>
           <a:xfrm>
-            <a:off x="4480560" y="3227831"/>
+            <a:off x="4480560" y="3330701"/>
             <a:ext cx="3200400" cy="4572"/>
           </a:xfrm>
           <a:prstGeom prst="rect">
@@ -11479,6 +11576,7 @@
           <a:lstStyle/>
           <a:p>
             <a:pPr algn="ctr"/>
+            <a:endParaRPr/>
           </a:p>
         </p:txBody>
       </p:sp>
@@ -11490,7 +11588,7 @@
         </p:nvSpPr>
         <p:spPr>
           <a:xfrm>
-            <a:off x="4480560" y="3273551"/>
+            <a:off x="4480560" y="3376421"/>
             <a:ext cx="2068372" cy="228600"/>
           </a:xfrm>
           <a:prstGeom prst="rect">
@@ -11526,7 +11624,7 @@
         </p:nvSpPr>
         <p:spPr>
           <a:xfrm>
-            <a:off x="6152083" y="3273551"/>
+            <a:off x="6152083" y="3376421"/>
             <a:ext cx="1497787" cy="228600"/>
           </a:xfrm>
           <a:prstGeom prst="rect">
@@ -11562,7 +11660,7 @@
         </p:nvSpPr>
         <p:spPr>
           <a:xfrm>
-            <a:off x="4480560" y="3520439"/>
+            <a:off x="4480560" y="3623309"/>
             <a:ext cx="3200400" cy="4572"/>
           </a:xfrm>
           <a:prstGeom prst="rect">
@@ -11594,6 +11692,7 @@
           <a:lstStyle/>
           <a:p>
             <a:pPr algn="ctr"/>
+            <a:endParaRPr/>
           </a:p>
         </p:txBody>
       </p:sp>
@@ -11605,7 +11704,7 @@
         </p:nvSpPr>
         <p:spPr>
           <a:xfrm>
-            <a:off x="4480560" y="3566159"/>
+            <a:off x="4480560" y="3669029"/>
             <a:ext cx="2068372" cy="228600"/>
           </a:xfrm>
           <a:prstGeom prst="rect">
@@ -11641,7 +11740,7 @@
         </p:nvSpPr>
         <p:spPr>
           <a:xfrm>
-            <a:off x="6152083" y="3566159"/>
+            <a:off x="6152083" y="3669029"/>
             <a:ext cx="1497787" cy="228600"/>
           </a:xfrm>
           <a:prstGeom prst="rect">
@@ -11677,7 +11776,7 @@
         </p:nvSpPr>
         <p:spPr>
           <a:xfrm>
-            <a:off x="4480560" y="3813047"/>
+            <a:off x="4480560" y="3915917"/>
             <a:ext cx="3200400" cy="4572"/>
           </a:xfrm>
           <a:prstGeom prst="rect">
@@ -11709,6 +11808,7 @@
           <a:lstStyle/>
           <a:p>
             <a:pPr algn="ctr"/>
+            <a:endParaRPr/>
           </a:p>
         </p:txBody>
       </p:sp>
@@ -11720,7 +11820,7 @@
         </p:nvSpPr>
         <p:spPr>
           <a:xfrm>
-            <a:off x="4480560" y="3904487"/>
+            <a:off x="4480560" y="4007357"/>
             <a:ext cx="3200400" cy="18288"/>
           </a:xfrm>
           <a:prstGeom prst="rect">
@@ -11752,6 +11852,7 @@
           <a:lstStyle/>
           <a:p>
             <a:pPr algn="ctr"/>
+            <a:endParaRPr/>
           </a:p>
         </p:txBody>
       </p:sp>
@@ -11763,7 +11864,7 @@
         </p:nvSpPr>
         <p:spPr>
           <a:xfrm>
-            <a:off x="4480560" y="3977639"/>
+            <a:off x="4480560" y="4080509"/>
             <a:ext cx="1783080" cy="274320"/>
           </a:xfrm>
           <a:prstGeom prst="rect">
@@ -11799,7 +11900,7 @@
         </p:nvSpPr>
         <p:spPr>
           <a:xfrm>
-            <a:off x="5902452" y="3977639"/>
+            <a:off x="5902452" y="4080509"/>
             <a:ext cx="1783080" cy="274320"/>
           </a:xfrm>
           <a:prstGeom prst="rect">
@@ -11835,7 +11936,7 @@
         </p:nvSpPr>
         <p:spPr>
           <a:xfrm>
-            <a:off x="8138160" y="1600200"/>
+            <a:off x="8138160" y="1703070"/>
             <a:ext cx="3566160" cy="2788920"/>
           </a:xfrm>
           <a:prstGeom prst="roundRect">
@@ -11869,6 +11970,7 @@
           <a:lstStyle/>
           <a:p>
             <a:pPr algn="ctr"/>
+            <a:endParaRPr/>
           </a:p>
         </p:txBody>
       </p:sp>
@@ -11880,7 +11982,7 @@
         </p:nvSpPr>
         <p:spPr>
           <a:xfrm>
-            <a:off x="8138160" y="1600200"/>
+            <a:off x="8138160" y="1703070"/>
             <a:ext cx="3566160" cy="411480"/>
           </a:xfrm>
           <a:prstGeom prst="rect">
@@ -11914,6 +12016,7 @@
           <a:lstStyle/>
           <a:p>
             <a:pPr algn="ctr"/>
+            <a:endParaRPr/>
           </a:p>
         </p:txBody>
       </p:sp>
@@ -11925,7 +12028,7 @@
         </p:nvSpPr>
         <p:spPr>
           <a:xfrm>
-            <a:off x="8321040" y="1673352"/>
+            <a:off x="8321040" y="1776222"/>
             <a:ext cx="3200400" cy="274320"/>
           </a:xfrm>
           <a:prstGeom prst="rect">
@@ -11961,7 +12064,7 @@
         </p:nvSpPr>
         <p:spPr>
           <a:xfrm>
-            <a:off x="8321040" y="2103120"/>
+            <a:off x="8321040" y="2205990"/>
             <a:ext cx="2068372" cy="228600"/>
           </a:xfrm>
           <a:prstGeom prst="rect">
@@ -11997,7 +12100,7 @@
         </p:nvSpPr>
         <p:spPr>
           <a:xfrm>
-            <a:off x="9992563" y="2103120"/>
+            <a:off x="9992563" y="2205990"/>
             <a:ext cx="1497787" cy="228600"/>
           </a:xfrm>
           <a:prstGeom prst="rect">
@@ -12033,7 +12136,7 @@
         </p:nvSpPr>
         <p:spPr>
           <a:xfrm>
-            <a:off x="8321040" y="2350008"/>
+            <a:off x="8321040" y="2452878"/>
             <a:ext cx="3200400" cy="4572"/>
           </a:xfrm>
           <a:prstGeom prst="rect">
@@ -12065,6 +12168,7 @@
           <a:lstStyle/>
           <a:p>
             <a:pPr algn="ctr"/>
+            <a:endParaRPr/>
           </a:p>
         </p:txBody>
       </p:sp>
@@ -12076,7 +12180,7 @@
         </p:nvSpPr>
         <p:spPr>
           <a:xfrm>
-            <a:off x="8321040" y="2395727"/>
+            <a:off x="8321040" y="2498597"/>
             <a:ext cx="2068372" cy="228600"/>
           </a:xfrm>
           <a:prstGeom prst="rect">
@@ -12112,7 +12216,7 @@
         </p:nvSpPr>
         <p:spPr>
           <a:xfrm>
-            <a:off x="9992563" y="2395727"/>
+            <a:off x="9992563" y="2498597"/>
             <a:ext cx="1497787" cy="228600"/>
           </a:xfrm>
           <a:prstGeom prst="rect">
@@ -12148,7 +12252,7 @@
         </p:nvSpPr>
         <p:spPr>
           <a:xfrm>
-            <a:off x="8321040" y="2642615"/>
+            <a:off x="8321040" y="2745485"/>
             <a:ext cx="3200400" cy="4572"/>
           </a:xfrm>
           <a:prstGeom prst="rect">
@@ -12180,6 +12284,7 @@
           <a:lstStyle/>
           <a:p>
             <a:pPr algn="ctr"/>
+            <a:endParaRPr/>
           </a:p>
         </p:txBody>
       </p:sp>
@@ -12191,7 +12296,7 @@
         </p:nvSpPr>
         <p:spPr>
           <a:xfrm>
-            <a:off x="8321040" y="2688335"/>
+            <a:off x="8321040" y="2791205"/>
             <a:ext cx="2068372" cy="228600"/>
           </a:xfrm>
           <a:prstGeom prst="rect">
@@ -12227,7 +12332,7 @@
         </p:nvSpPr>
         <p:spPr>
           <a:xfrm>
-            <a:off x="9992563" y="2688335"/>
+            <a:off x="9992563" y="2791205"/>
             <a:ext cx="1497787" cy="228600"/>
           </a:xfrm>
           <a:prstGeom prst="rect">
@@ -12263,7 +12368,7 @@
         </p:nvSpPr>
         <p:spPr>
           <a:xfrm>
-            <a:off x="8321040" y="2935223"/>
+            <a:off x="8321040" y="3038093"/>
             <a:ext cx="3200400" cy="4572"/>
           </a:xfrm>
           <a:prstGeom prst="rect">
@@ -12295,6 +12400,7 @@
           <a:lstStyle/>
           <a:p>
             <a:pPr algn="ctr"/>
+            <a:endParaRPr/>
           </a:p>
         </p:txBody>
       </p:sp>
@@ -12306,7 +12412,7 @@
         </p:nvSpPr>
         <p:spPr>
           <a:xfrm>
-            <a:off x="8321040" y="2980943"/>
+            <a:off x="8321040" y="3083813"/>
             <a:ext cx="2068372" cy="228600"/>
           </a:xfrm>
           <a:prstGeom prst="rect">
@@ -12342,7 +12448,7 @@
         </p:nvSpPr>
         <p:spPr>
           <a:xfrm>
-            <a:off x="9992563" y="2980943"/>
+            <a:off x="9992563" y="3083813"/>
             <a:ext cx="1497787" cy="228600"/>
           </a:xfrm>
           <a:prstGeom prst="rect">
@@ -12378,7 +12484,7 @@
         </p:nvSpPr>
         <p:spPr>
           <a:xfrm>
-            <a:off x="8321040" y="3227831"/>
+            <a:off x="8321040" y="3330701"/>
             <a:ext cx="3200400" cy="4572"/>
           </a:xfrm>
           <a:prstGeom prst="rect">
@@ -12410,6 +12516,7 @@
           <a:lstStyle/>
           <a:p>
             <a:pPr algn="ctr"/>
+            <a:endParaRPr/>
           </a:p>
         </p:txBody>
       </p:sp>
@@ -12421,7 +12528,7 @@
         </p:nvSpPr>
         <p:spPr>
           <a:xfrm>
-            <a:off x="8321040" y="3273551"/>
+            <a:off x="8321040" y="3376421"/>
             <a:ext cx="2068372" cy="228600"/>
           </a:xfrm>
           <a:prstGeom prst="rect">
@@ -12457,7 +12564,7 @@
         </p:nvSpPr>
         <p:spPr>
           <a:xfrm>
-            <a:off x="9992563" y="3273551"/>
+            <a:off x="9992563" y="3376421"/>
             <a:ext cx="1497787" cy="228600"/>
           </a:xfrm>
           <a:prstGeom prst="rect">
@@ -12493,7 +12600,7 @@
         </p:nvSpPr>
         <p:spPr>
           <a:xfrm>
-            <a:off x="8321040" y="3520439"/>
+            <a:off x="8321040" y="3623309"/>
             <a:ext cx="3200400" cy="4572"/>
           </a:xfrm>
           <a:prstGeom prst="rect">
@@ -12525,6 +12632,7 @@
           <a:lstStyle/>
           <a:p>
             <a:pPr algn="ctr"/>
+            <a:endParaRPr/>
           </a:p>
         </p:txBody>
       </p:sp>
@@ -12536,7 +12644,7 @@
         </p:nvSpPr>
         <p:spPr>
           <a:xfrm>
-            <a:off x="8321040" y="3611879"/>
+            <a:off x="8321040" y="3714749"/>
             <a:ext cx="3200400" cy="18288"/>
           </a:xfrm>
           <a:prstGeom prst="rect">
@@ -12568,6 +12676,7 @@
           <a:lstStyle/>
           <a:p>
             <a:pPr algn="ctr"/>
+            <a:endParaRPr/>
           </a:p>
         </p:txBody>
       </p:sp>
@@ -12579,7 +12688,7 @@
         </p:nvSpPr>
         <p:spPr>
           <a:xfrm>
-            <a:off x="8321040" y="3685031"/>
+            <a:off x="8321040" y="3787901"/>
             <a:ext cx="1783080" cy="274320"/>
           </a:xfrm>
           <a:prstGeom prst="rect">
@@ -12615,7 +12724,7 @@
         </p:nvSpPr>
         <p:spPr>
           <a:xfrm>
-            <a:off x="9742932" y="3685031"/>
+            <a:off x="9742932" y="3787901"/>
             <a:ext cx="1783080" cy="274320"/>
           </a:xfrm>
           <a:prstGeom prst="rect">
@@ -12651,8 +12760,8 @@
         </p:nvSpPr>
         <p:spPr>
           <a:xfrm>
-            <a:off x="457200" y="4572000"/>
-            <a:ext cx="5303520" cy="1417320"/>
+            <a:off x="457200" y="4697729"/>
+            <a:ext cx="5303520" cy="1618487"/>
           </a:xfrm>
           <a:prstGeom prst="roundRect">
             <a:avLst/>
@@ -12685,6 +12794,7 @@
           <a:lstStyle/>
           <a:p>
             <a:pPr algn="ctr"/>
+            <a:endParaRPr/>
           </a:p>
         </p:txBody>
       </p:sp>
@@ -12696,7 +12806,7 @@
         </p:nvSpPr>
         <p:spPr>
           <a:xfrm>
-            <a:off x="457200" y="4572000"/>
+            <a:off x="457200" y="4697730"/>
             <a:ext cx="5303520" cy="411480"/>
           </a:xfrm>
           <a:prstGeom prst="rect">
@@ -12730,6 +12840,7 @@
           <a:lstStyle/>
           <a:p>
             <a:pPr algn="ctr"/>
+            <a:endParaRPr/>
           </a:p>
         </p:txBody>
       </p:sp>
@@ -12741,7 +12852,7 @@
         </p:nvSpPr>
         <p:spPr>
           <a:xfrm>
-            <a:off x="640080" y="4645152"/>
+            <a:off x="640080" y="4770882"/>
             <a:ext cx="4937759" cy="274320"/>
           </a:xfrm>
           <a:prstGeom prst="rect">
@@ -12777,7 +12888,7 @@
         </p:nvSpPr>
         <p:spPr>
           <a:xfrm>
-            <a:off x="640080" y="5074920"/>
+            <a:off x="640080" y="5200650"/>
             <a:ext cx="3076041" cy="228600"/>
           </a:xfrm>
           <a:prstGeom prst="rect">
@@ -12813,7 +12924,7 @@
         </p:nvSpPr>
         <p:spPr>
           <a:xfrm>
-            <a:off x="3215030" y="5074920"/>
+            <a:off x="3215030" y="5200650"/>
             <a:ext cx="2227478" cy="228600"/>
           </a:xfrm>
           <a:prstGeom prst="rect">
@@ -12849,7 +12960,7 @@
         </p:nvSpPr>
         <p:spPr>
           <a:xfrm>
-            <a:off x="640080" y="5321808"/>
+            <a:off x="640080" y="5447538"/>
             <a:ext cx="4937759" cy="4572"/>
           </a:xfrm>
           <a:prstGeom prst="rect">
@@ -12881,6 +12992,7 @@
           <a:lstStyle/>
           <a:p>
             <a:pPr algn="ctr"/>
+            <a:endParaRPr/>
           </a:p>
         </p:txBody>
       </p:sp>
@@ -12892,7 +13004,7 @@
         </p:nvSpPr>
         <p:spPr>
           <a:xfrm>
-            <a:off x="640080" y="5367528"/>
+            <a:off x="640080" y="5493258"/>
             <a:ext cx="3076041" cy="228600"/>
           </a:xfrm>
           <a:prstGeom prst="rect">
@@ -12928,7 +13040,7 @@
         </p:nvSpPr>
         <p:spPr>
           <a:xfrm>
-            <a:off x="3215030" y="5367528"/>
+            <a:off x="3215030" y="5493258"/>
             <a:ext cx="2227478" cy="228600"/>
           </a:xfrm>
           <a:prstGeom prst="rect">
@@ -12964,7 +13076,7 @@
         </p:nvSpPr>
         <p:spPr>
           <a:xfrm>
-            <a:off x="640080" y="5614416"/>
+            <a:off x="640080" y="5740146"/>
             <a:ext cx="4937759" cy="4572"/>
           </a:xfrm>
           <a:prstGeom prst="rect">
@@ -12996,6 +13108,7 @@
           <a:lstStyle/>
           <a:p>
             <a:pPr algn="ctr"/>
+            <a:endParaRPr/>
           </a:p>
         </p:txBody>
       </p:sp>
@@ -13007,7 +13120,7 @@
         </p:nvSpPr>
         <p:spPr>
           <a:xfrm>
-            <a:off x="640080" y="5705856"/>
+            <a:off x="640080" y="5831586"/>
             <a:ext cx="4937759" cy="18288"/>
           </a:xfrm>
           <a:prstGeom prst="rect">
@@ -13039,6 +13152,7 @@
           <a:lstStyle/>
           <a:p>
             <a:pPr algn="ctr"/>
+            <a:endParaRPr/>
           </a:p>
         </p:txBody>
       </p:sp>
@@ -13050,7 +13164,7 @@
         </p:nvSpPr>
         <p:spPr>
           <a:xfrm>
-            <a:off x="640080" y="5779008"/>
+            <a:off x="640080" y="5904738"/>
             <a:ext cx="2651760" cy="274320"/>
           </a:xfrm>
           <a:prstGeom prst="rect">
@@ -13073,6 +13187,7 @@
               </a:defRPr>
             </a:pPr>
             <a:r>
+              <a:rPr dirty="0"/>
               <a:t>POC Total Investment</a:t>
             </a:r>
           </a:p>
@@ -13086,7 +13201,7 @@
         </p:nvSpPr>
         <p:spPr>
           <a:xfrm>
-            <a:off x="2843784" y="5779008"/>
+            <a:off x="2843784" y="5904738"/>
             <a:ext cx="2651760" cy="274320"/>
           </a:xfrm>
           <a:prstGeom prst="rect">
@@ -13122,8 +13237,8 @@
         </p:nvSpPr>
         <p:spPr>
           <a:xfrm>
-            <a:off x="6035040" y="4572000"/>
-            <a:ext cx="5669280" cy="1417320"/>
+            <a:off x="6035040" y="4697730"/>
+            <a:ext cx="5669280" cy="1618486"/>
           </a:xfrm>
           <a:prstGeom prst="roundRect">
             <a:avLst/>
@@ -13156,6 +13271,7 @@
           <a:lstStyle/>
           <a:p>
             <a:pPr algn="ctr"/>
+            <a:endParaRPr/>
           </a:p>
         </p:txBody>
       </p:sp>
@@ -13167,7 +13283,7 @@
         </p:nvSpPr>
         <p:spPr>
           <a:xfrm>
-            <a:off x="6035040" y="4572000"/>
+            <a:off x="6035040" y="4697730"/>
             <a:ext cx="5669280" cy="365760"/>
           </a:xfrm>
           <a:prstGeom prst="rect">
@@ -13201,6 +13317,7 @@
           <a:lstStyle/>
           <a:p>
             <a:pPr algn="ctr"/>
+            <a:endParaRPr/>
           </a:p>
         </p:txBody>
       </p:sp>
@@ -13212,7 +13329,7 @@
         </p:nvSpPr>
         <p:spPr>
           <a:xfrm>
-            <a:off x="6263640" y="4636008"/>
+            <a:off x="6263640" y="4761738"/>
             <a:ext cx="4572000" cy="256032"/>
           </a:xfrm>
           <a:prstGeom prst="rect">
@@ -13248,7 +13365,7 @@
         </p:nvSpPr>
         <p:spPr>
           <a:xfrm>
-            <a:off x="6309360" y="5056632"/>
+            <a:off x="6309360" y="5182362"/>
             <a:ext cx="45720" cy="45720"/>
           </a:xfrm>
           <a:prstGeom prst="ellipse">
@@ -13280,6 +13397,7 @@
           <a:lstStyle/>
           <a:p>
             <a:pPr algn="ctr"/>
+            <a:endParaRPr/>
           </a:p>
         </p:txBody>
       </p:sp>
@@ -13291,7 +13409,7 @@
         </p:nvSpPr>
         <p:spPr>
           <a:xfrm>
-            <a:off x="6446520" y="5010912"/>
+            <a:off x="6446520" y="5136642"/>
             <a:ext cx="5029200" cy="182880"/>
           </a:xfrm>
           <a:prstGeom prst="rect">
@@ -13327,7 +13445,7 @@
         </p:nvSpPr>
         <p:spPr>
           <a:xfrm>
-            <a:off x="6309360" y="5239512"/>
+            <a:off x="6309360" y="5365242"/>
             <a:ext cx="45720" cy="45720"/>
           </a:xfrm>
           <a:prstGeom prst="ellipse">
@@ -13359,6 +13477,7 @@
           <a:lstStyle/>
           <a:p>
             <a:pPr algn="ctr"/>
+            <a:endParaRPr/>
           </a:p>
         </p:txBody>
       </p:sp>
@@ -13370,7 +13489,7 @@
         </p:nvSpPr>
         <p:spPr>
           <a:xfrm>
-            <a:off x="6446520" y="5193792"/>
+            <a:off x="6446520" y="5319522"/>
             <a:ext cx="5029200" cy="182880"/>
           </a:xfrm>
           <a:prstGeom prst="rect">
@@ -13406,7 +13525,7 @@
         </p:nvSpPr>
         <p:spPr>
           <a:xfrm>
-            <a:off x="6309360" y="5422392"/>
+            <a:off x="6309360" y="5548122"/>
             <a:ext cx="45720" cy="45720"/>
           </a:xfrm>
           <a:prstGeom prst="ellipse">
@@ -13438,6 +13557,7 @@
           <a:lstStyle/>
           <a:p>
             <a:pPr algn="ctr"/>
+            <a:endParaRPr/>
           </a:p>
         </p:txBody>
       </p:sp>
@@ -13449,7 +13569,7 @@
         </p:nvSpPr>
         <p:spPr>
           <a:xfrm>
-            <a:off x="6446520" y="5376672"/>
+            <a:off x="6446520" y="5502402"/>
             <a:ext cx="5029200" cy="182880"/>
           </a:xfrm>
           <a:prstGeom prst="rect">
@@ -13485,7 +13605,7 @@
         </p:nvSpPr>
         <p:spPr>
           <a:xfrm>
-            <a:off x="6309360" y="5605272"/>
+            <a:off x="6309360" y="5731002"/>
             <a:ext cx="45720" cy="45720"/>
           </a:xfrm>
           <a:prstGeom prst="ellipse">
@@ -13517,6 +13637,7 @@
           <a:lstStyle/>
           <a:p>
             <a:pPr algn="ctr"/>
+            <a:endParaRPr/>
           </a:p>
         </p:txBody>
       </p:sp>
@@ -13528,7 +13649,7 @@
         </p:nvSpPr>
         <p:spPr>
           <a:xfrm>
-            <a:off x="6446520" y="5559552"/>
+            <a:off x="6446520" y="5685282"/>
             <a:ext cx="5029200" cy="182880"/>
           </a:xfrm>
           <a:prstGeom prst="rect">
@@ -13564,7 +13685,7 @@
         </p:nvSpPr>
         <p:spPr>
           <a:xfrm>
-            <a:off x="6309360" y="5788152"/>
+            <a:off x="6309360" y="5913882"/>
             <a:ext cx="45720" cy="45720"/>
           </a:xfrm>
           <a:prstGeom prst="ellipse">
@@ -13596,6 +13717,7 @@
           <a:lstStyle/>
           <a:p>
             <a:pPr algn="ctr"/>
+            <a:endParaRPr/>
           </a:p>
         </p:txBody>
       </p:sp>
@@ -13607,7 +13729,7 @@
         </p:nvSpPr>
         <p:spPr>
           <a:xfrm>
-            <a:off x="6446520" y="5742432"/>
+            <a:off x="6446520" y="5868162"/>
             <a:ext cx="5029200" cy="182880"/>
           </a:xfrm>
           <a:prstGeom prst="rect">

</xml_diff>